<commit_message>
Updated slides and draft readme
</commit_message>
<xml_diff>
--- a/icane-pitch/iCane Pitch Draft.pptx
+++ b/icane-pitch/iCane Pitch Draft.pptx
@@ -1109,7 +1109,7 @@
             </a:pPr>
             <a:r>
               <a:rPr lang="en"/>
-              <a:t>Have website pulled up </a:t>
+              <a:t>Have website pulled up and highlight conclusion</a:t>
             </a:r>
             <a:endParaRPr/>
           </a:p>
@@ -1957,7 +1957,7 @@
   <p:cSld>
     <p:spTree>
       <p:nvGrpSpPr>
-        <p:cNvPr id="216" name="Shape 216"/>
+        <p:cNvPr id="211" name="Shape 211"/>
         <p:cNvGrpSpPr/>
         <p:nvPr/>
       </p:nvGrpSpPr>
@@ -1971,7 +1971,7 @@
       </p:grpSpPr>
       <p:sp>
         <p:nvSpPr>
-          <p:cNvPr id="217" name="Google Shape;217;g3fbaa4c43d1_3_139:notes"/>
+          <p:cNvPr id="212" name="Google Shape;212;g3fbaa4c43d1_3_139:notes"/>
           <p:cNvSpPr/>
           <p:nvPr>
             <p:ph idx="2" type="sldImg"/>
@@ -2016,7 +2016,7 @@
       </p:sp>
       <p:sp>
         <p:nvSpPr>
-          <p:cNvPr id="218" name="Google Shape;218;g3fbaa4c43d1_3_139:notes"/>
+          <p:cNvPr id="213" name="Google Shape;213;g3fbaa4c43d1_3_139:notes"/>
           <p:cNvSpPr txBox="1"/>
           <p:nvPr>
             <p:ph idx="1" type="body"/>
@@ -2059,7 +2059,7 @@
       </p:sp>
       <p:sp>
         <p:nvSpPr>
-          <p:cNvPr id="219" name="Google Shape;219;g3fbaa4c43d1_3_139:notes"/>
+          <p:cNvPr id="214" name="Google Shape;214;g3fbaa4c43d1_3_139:notes"/>
           <p:cNvSpPr txBox="1"/>
           <p:nvPr>
             <p:ph idx="12" type="sldNum"/>
@@ -9064,9 +9064,9 @@
               <a:t>Source: </a:t>
             </a:r>
             <a:r>
-              <a:rPr b="0" i="0" lang="en" sz="1200" u="sng" cap="none" strike="noStrike">
+              <a:rPr lang="en" sz="1200" u="sng">
                 <a:solidFill>
-                  <a:srgbClr val="3D85C6"/>
+                  <a:srgbClr val="6FA8DC"/>
                 </a:solidFill>
                 <a:latin typeface="Calibri"/>
                 <a:ea typeface="Calibri"/>
@@ -9080,11 +9080,11 @@
                   </a:extLst>
                 </a:hlinkClick>
               </a:rPr>
-              <a:t>National Institutes of Health</a:t>
+              <a:t>National Library of Medicine</a:t>
             </a:r>
             <a:endParaRPr b="0" i="0" sz="1200" u="none" cap="none" strike="noStrike">
               <a:solidFill>
-                <a:srgbClr val="3D85C6"/>
+                <a:srgbClr val="6FA8DC"/>
               </a:solidFill>
               <a:latin typeface="Calibri"/>
               <a:ea typeface="Calibri"/>
@@ -9166,7 +9166,7 @@
               <a:buNone/>
             </a:pPr>
             <a:r>
-              <a:rPr b="1" i="0" lang="en" sz="3600" u="none" cap="none" strike="noStrike">
+              <a:rPr b="1" lang="en" sz="3600">
                 <a:solidFill>
                   <a:srgbClr val="1B1F2A"/>
                 </a:solidFill>
@@ -9175,7 +9175,7 @@
                 <a:cs typeface="Cambria"/>
                 <a:sym typeface="Cambria"/>
               </a:rPr>
-              <a:t>What that looks like</a:t>
+              <a:t>R</a:t>
             </a:r>
             <a:r>
               <a:rPr b="1" i="0" lang="en" sz="3600" u="none" cap="none" strike="noStrike">
@@ -9187,7 +9187,19 @@
                 <a:cs typeface="Cambria"/>
                 <a:sym typeface="Cambria"/>
               </a:rPr>
-              <a:t> in real life</a:t>
+              <a:t>eal </a:t>
+            </a:r>
+            <a:r>
+              <a:rPr b="1" lang="en" sz="3600">
+                <a:solidFill>
+                  <a:srgbClr val="1B1F2A"/>
+                </a:solidFill>
+                <a:latin typeface="Cambria"/>
+                <a:ea typeface="Cambria"/>
+                <a:cs typeface="Cambria"/>
+                <a:sym typeface="Cambria"/>
+              </a:rPr>
+              <a:t>world problems</a:t>
             </a:r>
             <a:endParaRPr b="0" i="0" sz="3600" u="none" cap="none" strike="noStrike">
               <a:solidFill>
@@ -10620,6 +10632,18 @@
               <a:buNone/>
             </a:pPr>
             <a:r>
+              <a:rPr b="1" lang="en" sz="1800">
+                <a:solidFill>
+                  <a:srgbClr val="12151C"/>
+                </a:solidFill>
+                <a:latin typeface="Calibri"/>
+                <a:ea typeface="Calibri"/>
+                <a:cs typeface="Calibri"/>
+                <a:sym typeface="Calibri"/>
+              </a:rPr>
+              <a:t>T</a:t>
+            </a:r>
+            <a:r>
               <a:rPr b="1" i="0" lang="en" sz="1800" u="none" cap="none" strike="noStrike">
                 <a:solidFill>
                   <a:srgbClr val="12151C"/>
@@ -10629,7 +10653,19 @@
                 <a:cs typeface="Calibri"/>
                 <a:sym typeface="Calibri"/>
               </a:rPr>
-              <a:t>Plus: tap anytime to ask what's in the scene.</a:t>
+              <a:t>ap a button anytime </a:t>
+            </a:r>
+            <a:r>
+              <a:rPr b="1" lang="en" sz="1800">
+                <a:solidFill>
+                  <a:srgbClr val="12151C"/>
+                </a:solidFill>
+                <a:latin typeface="Calibri"/>
+                <a:ea typeface="Calibri"/>
+                <a:cs typeface="Calibri"/>
+                <a:sym typeface="Calibri"/>
+              </a:rPr>
+              <a:t>for a scan of your environment.</a:t>
             </a:r>
             <a:endParaRPr b="0" i="0" sz="1800" u="none" cap="none" strike="noStrike">
               <a:solidFill>
@@ -10977,7 +11013,31 @@
                 <a:cs typeface="Calibri"/>
                 <a:sym typeface="Calibri"/>
               </a:rPr>
-              <a:t>Calls it out once, with direction.</a:t>
+              <a:t>Calls it out with direction and </a:t>
+            </a:r>
+            <a:r>
+              <a:rPr lang="en" sz="1100">
+                <a:solidFill>
+                  <a:srgbClr val="5B6472"/>
+                </a:solidFill>
+                <a:latin typeface="Calibri"/>
+                <a:ea typeface="Calibri"/>
+                <a:cs typeface="Calibri"/>
+                <a:sym typeface="Calibri"/>
+              </a:rPr>
+              <a:t>distance.</a:t>
+            </a:r>
+            <a:r>
+              <a:rPr b="0" i="0" lang="en" sz="1100" u="none" cap="none" strike="noStrike">
+                <a:solidFill>
+                  <a:srgbClr val="5B6472"/>
+                </a:solidFill>
+                <a:latin typeface="Calibri"/>
+                <a:ea typeface="Calibri"/>
+                <a:cs typeface="Calibri"/>
+                <a:sym typeface="Calibri"/>
+              </a:rPr>
+              <a:t>.</a:t>
             </a:r>
             <a:endParaRPr b="0" i="0" sz="1100" u="none" cap="none" strike="noStrike">
               <a:solidFill>
@@ -11230,7 +11290,19 @@
                 <a:cs typeface="Calibri"/>
                 <a:sym typeface="Calibri"/>
               </a:rPr>
-              <a:t>Warns as they close in, even from the side.</a:t>
+              <a:t>Warns as they close in</a:t>
+            </a:r>
+            <a:r>
+              <a:rPr lang="en" sz="1100">
+                <a:solidFill>
+                  <a:srgbClr val="5B6472"/>
+                </a:solidFill>
+                <a:latin typeface="Calibri"/>
+                <a:ea typeface="Calibri"/>
+                <a:cs typeface="Calibri"/>
+                <a:sym typeface="Calibri"/>
+              </a:rPr>
+              <a:t>.</a:t>
             </a:r>
             <a:endParaRPr b="0" i="0" sz="1100" u="none" cap="none" strike="noStrike">
               <a:solidFill>
@@ -11483,7 +11555,43 @@
                 <a:cs typeface="Calibri"/>
                 <a:sym typeface="Calibri"/>
               </a:rPr>
-              <a:t>Flags the drop before you step.</a:t>
+              <a:t>Flags the </a:t>
+            </a:r>
+            <a:r>
+              <a:rPr lang="en" sz="1100">
+                <a:solidFill>
+                  <a:srgbClr val="5B6472"/>
+                </a:solidFill>
+                <a:latin typeface="Calibri"/>
+                <a:ea typeface="Calibri"/>
+                <a:cs typeface="Calibri"/>
+                <a:sym typeface="Calibri"/>
+              </a:rPr>
+              <a:t>elevation change </a:t>
+            </a:r>
+            <a:r>
+              <a:rPr b="0" i="0" lang="en" sz="1100" u="none" cap="none" strike="noStrike">
+                <a:solidFill>
+                  <a:srgbClr val="5B6472"/>
+                </a:solidFill>
+                <a:latin typeface="Calibri"/>
+                <a:ea typeface="Calibri"/>
+                <a:cs typeface="Calibri"/>
+                <a:sym typeface="Calibri"/>
+              </a:rPr>
+              <a:t>before you </a:t>
+            </a:r>
+            <a:r>
+              <a:rPr b="0" i="0" lang="en" sz="1100" u="none" cap="none" strike="noStrike">
+                <a:solidFill>
+                  <a:srgbClr val="5B6472"/>
+                </a:solidFill>
+                <a:latin typeface="Calibri"/>
+                <a:ea typeface="Calibri"/>
+                <a:cs typeface="Calibri"/>
+                <a:sym typeface="Calibri"/>
+              </a:rPr>
+              <a:t>step.</a:t>
             </a:r>
             <a:endParaRPr b="0" i="0" sz="1100" u="none" cap="none" strike="noStrike">
               <a:solidFill>
@@ -13011,7 +13119,7 @@
               <a:buNone/>
             </a:pPr>
             <a:r>
-              <a:rPr b="1" i="0" lang="en" sz="2200" u="none" cap="none" strike="noStrike">
+              <a:rPr b="1" lang="en" sz="2200">
                 <a:solidFill>
                   <a:srgbClr val="1B1F2A"/>
                 </a:solidFill>
@@ -13020,7 +13128,7 @@
                 <a:cs typeface="Cambria"/>
                 <a:sym typeface="Cambria"/>
               </a:rPr>
-              <a:t>Needs a human</a:t>
+              <a:t>Relies on another human</a:t>
             </a:r>
             <a:endParaRPr b="0" i="0" sz="2200" u="none" cap="none" strike="noStrike">
               <a:solidFill>
@@ -13363,6 +13471,18 @@
               <a:buChar char="•"/>
             </a:pPr>
             <a:r>
+              <a:rPr lang="en">
+                <a:solidFill>
+                  <a:srgbClr val="5B6472"/>
+                </a:solidFill>
+                <a:latin typeface="Calibri"/>
+                <a:ea typeface="Calibri"/>
+                <a:cs typeface="Calibri"/>
+                <a:sym typeface="Calibri"/>
+              </a:rPr>
+              <a:t>Base price of</a:t>
+            </a:r>
+            <a:r>
               <a:rPr b="0" i="0" lang="en" sz="1400" u="none" cap="none" strike="noStrike">
                 <a:solidFill>
                   <a:srgbClr val="5B6472"/>
@@ -13372,7 +13492,7 @@
                 <a:cs typeface="Calibri"/>
                 <a:sym typeface="Calibri"/>
               </a:rPr>
-              <a:t>Newest model: $799</a:t>
+              <a:t> $799</a:t>
             </a:r>
             <a:endParaRPr b="0" i="0" sz="1400" u="none" cap="none" strike="noStrike">
               <a:solidFill>
@@ -13437,6 +13557,18 @@
               <a:buChar char="•"/>
             </a:pPr>
             <a:r>
+              <a:rPr lang="en">
+                <a:solidFill>
+                  <a:srgbClr val="5B6472"/>
+                </a:solidFill>
+                <a:latin typeface="Calibri"/>
+                <a:ea typeface="Calibri"/>
+                <a:cs typeface="Calibri"/>
+                <a:sym typeface="Calibri"/>
+              </a:rPr>
+              <a:t>E</a:t>
+            </a:r>
+            <a:r>
               <a:rPr b="0" i="0" lang="en" sz="1400" u="none" cap="none" strike="noStrike">
                 <a:solidFill>
                   <a:srgbClr val="5B6472"/>
@@ -13446,7 +13578,31 @@
                 <a:cs typeface="Calibri"/>
                 <a:sym typeface="Calibri"/>
               </a:rPr>
-              <a:t>Cheaper earlier model no longer offered on the official site</a:t>
+              <a:t>arlier model ($</a:t>
+            </a:r>
+            <a:r>
+              <a:rPr lang="en">
+                <a:solidFill>
+                  <a:srgbClr val="5B6472"/>
+                </a:solidFill>
+                <a:latin typeface="Calibri"/>
+                <a:ea typeface="Calibri"/>
+                <a:cs typeface="Calibri"/>
+                <a:sym typeface="Calibri"/>
+              </a:rPr>
+              <a:t>599.95) </a:t>
+            </a:r>
+            <a:r>
+              <a:rPr b="0" i="0" lang="en" sz="1400" u="none" cap="none" strike="noStrike">
+                <a:solidFill>
+                  <a:srgbClr val="5B6472"/>
+                </a:solidFill>
+                <a:latin typeface="Calibri"/>
+                <a:ea typeface="Calibri"/>
+                <a:cs typeface="Calibri"/>
+                <a:sym typeface="Calibri"/>
+              </a:rPr>
+              <a:t>no longer offered on the official site</a:t>
             </a:r>
             <a:endParaRPr b="0" i="0" sz="1400" u="none" cap="none" strike="noStrike">
               <a:solidFill>
@@ -13551,6 +13707,18 @@
               <a:buNone/>
             </a:pPr>
             <a:r>
+              <a:rPr b="1" lang="en" sz="1800">
+                <a:solidFill>
+                  <a:srgbClr val="FFFFFF"/>
+                </a:solidFill>
+                <a:latin typeface="Calibri"/>
+                <a:ea typeface="Calibri"/>
+                <a:cs typeface="Calibri"/>
+                <a:sym typeface="Calibri"/>
+              </a:rPr>
+              <a:t>i</a:t>
+            </a:r>
+            <a:r>
               <a:rPr b="1" i="0" lang="en" sz="1800" u="none" cap="none" strike="noStrike">
                 <a:solidFill>
                   <a:srgbClr val="FFFFFF"/>
@@ -13560,7 +13728,7 @@
                 <a:cs typeface="Calibri"/>
                 <a:sym typeface="Calibri"/>
               </a:rPr>
-              <a:t>Walk-Assist Cane</a:t>
+              <a:t>Cane</a:t>
             </a:r>
             <a:endParaRPr b="0" i="0" sz="1800" u="none" cap="none" strike="noStrike">
               <a:solidFill>
@@ -13686,7 +13854,43 @@
                 <a:cs typeface="Calibri"/>
                 <a:sym typeface="Calibri"/>
               </a:rPr>
-              <a:t>Always on, with no one to call</a:t>
+              <a:t>Always on</a:t>
+            </a:r>
+            <a:r>
+              <a:rPr b="0" i="0" lang="en" sz="1400" u="none" cap="none" strike="noStrike">
+                <a:solidFill>
+                  <a:srgbClr val="C9CED8"/>
+                </a:solidFill>
+                <a:latin typeface="Calibri"/>
+                <a:ea typeface="Calibri"/>
+                <a:cs typeface="Calibri"/>
+                <a:sym typeface="Calibri"/>
+              </a:rPr>
+              <a:t>, </a:t>
+            </a:r>
+            <a:r>
+              <a:rPr b="0" i="0" lang="en" sz="1400" u="none" cap="none" strike="noStrike">
+                <a:solidFill>
+                  <a:srgbClr val="C9CED8"/>
+                </a:solidFill>
+                <a:latin typeface="Calibri"/>
+                <a:ea typeface="Calibri"/>
+                <a:cs typeface="Calibri"/>
+                <a:sym typeface="Calibri"/>
+              </a:rPr>
+              <a:t>no call nee</a:t>
+            </a:r>
+            <a:r>
+              <a:rPr lang="en">
+                <a:solidFill>
+                  <a:srgbClr val="C9CED8"/>
+                </a:solidFill>
+                <a:latin typeface="Calibri"/>
+                <a:ea typeface="Calibri"/>
+                <a:cs typeface="Calibri"/>
+                <a:sym typeface="Calibri"/>
+              </a:rPr>
+              <a:t>ded</a:t>
             </a:r>
             <a:endParaRPr b="0" i="0" sz="1400" u="none" cap="none" strike="noStrike">
               <a:solidFill>
@@ -13877,8 +14081,8 @@
         </p:nvSpPr>
         <p:spPr>
           <a:xfrm>
-            <a:off x="457200" y="1417320"/>
-            <a:ext cx="2560200" cy="2331600"/>
+            <a:off x="457200" y="1405950"/>
+            <a:ext cx="3870900" cy="2331600"/>
           </a:xfrm>
           <a:prstGeom prst="roundRect">
             <a:avLst>
@@ -13928,7 +14132,7 @@
         </p:nvSpPr>
         <p:spPr>
           <a:xfrm>
-            <a:off x="731520" y="1645920"/>
+            <a:off x="731510" y="1634545"/>
             <a:ext cx="731400" cy="731400"/>
           </a:xfrm>
           <a:prstGeom prst="ellipse">
@@ -13977,233 +14181,7 @@
         </p:nvSpPr>
         <p:spPr>
           <a:xfrm>
-            <a:off x="731520" y="2514600"/>
-            <a:ext cx="2103000" cy="365700"/>
-          </a:xfrm>
-          <a:prstGeom prst="rect">
-            <a:avLst/>
-          </a:prstGeom>
-          <a:noFill/>
-          <a:ln>
-            <a:noFill/>
-          </a:ln>
-        </p:spPr>
-        <p:txBody>
-          <a:bodyPr anchorCtr="0" anchor="ctr" bIns="0" lIns="0" spcFirstLastPara="1" rIns="0" wrap="square" tIns="0">
-            <a:noAutofit/>
-          </a:bodyPr>
-          <a:lstStyle/>
-          <a:p>
-            <a:pPr indent="0" lvl="0" marL="0" marR="0" rtl="0" algn="l">
-              <a:spcBef>
-                <a:spcPts val="0"/>
-              </a:spcBef>
-              <a:spcAft>
-                <a:spcPts val="0"/>
-              </a:spcAft>
-              <a:buClr>
-                <a:srgbClr val="1B1F2A"/>
-              </a:buClr>
-              <a:buSzPts val="2000"/>
-              <a:buFont typeface="Calibri"/>
-              <a:buNone/>
-            </a:pPr>
-            <a:r>
-              <a:rPr b="1" lang="en" sz="2000">
-                <a:solidFill>
-                  <a:srgbClr val="1B1F2A"/>
-                </a:solidFill>
-                <a:latin typeface="Calibri"/>
-                <a:ea typeface="Calibri"/>
-                <a:cs typeface="Calibri"/>
-                <a:sym typeface="Calibri"/>
-              </a:rPr>
-              <a:t>Know how far</a:t>
-            </a:r>
-            <a:endParaRPr b="0" i="0" sz="2000" u="none" cap="none" strike="noStrike">
-              <a:solidFill>
-                <a:schemeClr val="dk1"/>
-              </a:solidFill>
-              <a:latin typeface="Calibri"/>
-              <a:ea typeface="Calibri"/>
-              <a:cs typeface="Calibri"/>
-              <a:sym typeface="Calibri"/>
-            </a:endParaRPr>
-          </a:p>
-        </p:txBody>
-      </p:sp>
-      <p:sp>
-        <p:nvSpPr>
-          <p:cNvPr id="202" name="Google Shape;202;p22"/>
-          <p:cNvSpPr txBox="1"/>
-          <p:nvPr/>
-        </p:nvSpPr>
-        <p:spPr>
-          <a:xfrm>
-            <a:off x="731520" y="2926080"/>
-            <a:ext cx="2103000" cy="731400"/>
-          </a:xfrm>
-          <a:prstGeom prst="rect">
-            <a:avLst/>
-          </a:prstGeom>
-          <a:noFill/>
-          <a:ln>
-            <a:noFill/>
-          </a:ln>
-        </p:spPr>
-        <p:txBody>
-          <a:bodyPr anchorCtr="0" anchor="t" bIns="0" lIns="0" spcFirstLastPara="1" rIns="0" wrap="square" tIns="0">
-            <a:noAutofit/>
-          </a:bodyPr>
-          <a:lstStyle/>
-          <a:p>
-            <a:pPr indent="0" lvl="0" marL="0" rtl="0" algn="l">
-              <a:spcBef>
-                <a:spcPts val="0"/>
-              </a:spcBef>
-              <a:spcAft>
-                <a:spcPts val="0"/>
-              </a:spcAft>
-              <a:buClr>
-                <a:srgbClr val="5B6472"/>
-              </a:buClr>
-              <a:buSzPts val="1400"/>
-              <a:buFont typeface="Calibri"/>
-              <a:buNone/>
-            </a:pPr>
-            <a:r>
-              <a:rPr lang="en">
-                <a:solidFill>
-                  <a:srgbClr val="5B6472"/>
-                </a:solidFill>
-                <a:latin typeface="Calibri"/>
-                <a:ea typeface="Calibri"/>
-                <a:cs typeface="Calibri"/>
-                <a:sym typeface="Calibri"/>
-              </a:rPr>
-              <a:t>Depth sensing now gives an estimate for how far an obstacle is.</a:t>
-            </a:r>
-            <a:endParaRPr>
-              <a:solidFill>
-                <a:srgbClr val="5B6472"/>
-              </a:solidFill>
-              <a:latin typeface="Calibri"/>
-              <a:ea typeface="Calibri"/>
-              <a:cs typeface="Calibri"/>
-              <a:sym typeface="Calibri"/>
-            </a:endParaRPr>
-          </a:p>
-        </p:txBody>
-      </p:sp>
-      <p:sp>
-        <p:nvSpPr>
-          <p:cNvPr id="203" name="Google Shape;203;p22"/>
-          <p:cNvSpPr/>
-          <p:nvPr/>
-        </p:nvSpPr>
-        <p:spPr>
-          <a:xfrm>
-            <a:off x="3291840" y="1417320"/>
-            <a:ext cx="2560200" cy="2331600"/>
-          </a:xfrm>
-          <a:prstGeom prst="roundRect">
-            <a:avLst>
-              <a:gd fmla="val 5882" name="adj"/>
-            </a:avLst>
-          </a:prstGeom>
-          <a:solidFill>
-            <a:srgbClr val="F1F3F6"/>
-          </a:solidFill>
-          <a:ln cap="flat" cmpd="sng" w="12700">
-            <a:solidFill>
-              <a:srgbClr val="F1F3F6"/>
-            </a:solidFill>
-            <a:prstDash val="solid"/>
-            <a:round/>
-            <a:headEnd len="sm" w="sm" type="none"/>
-            <a:tailEnd len="sm" w="sm" type="none"/>
-          </a:ln>
-        </p:spPr>
-        <p:txBody>
-          <a:bodyPr anchorCtr="0" anchor="ctr" bIns="91425" lIns="91425" spcFirstLastPara="1" rIns="91425" wrap="square" tIns="91425">
-            <a:noAutofit/>
-          </a:bodyPr>
-          <a:lstStyle/>
-          <a:p>
-            <a:pPr indent="0" lvl="0" marL="0" rtl="0" algn="l">
-              <a:spcBef>
-                <a:spcPts val="0"/>
-              </a:spcBef>
-              <a:spcAft>
-                <a:spcPts val="0"/>
-              </a:spcAft>
-              <a:buNone/>
-            </a:pPr>
-            <a:r>
-              <a:t/>
-            </a:r>
-            <a:endParaRPr/>
-          </a:p>
-        </p:txBody>
-      </p:sp>
-      <p:sp>
-        <p:nvSpPr>
-          <p:cNvPr id="204" name="Google Shape;204;p22"/>
-          <p:cNvSpPr/>
-          <p:nvPr/>
-        </p:nvSpPr>
-        <p:spPr>
-          <a:xfrm>
-            <a:off x="3566160" y="1645920"/>
-            <a:ext cx="731400" cy="731400"/>
-          </a:xfrm>
-          <a:prstGeom prst="ellipse">
-            <a:avLst/>
-          </a:prstGeom>
-          <a:solidFill>
-            <a:srgbClr val="FFC93C"/>
-          </a:solidFill>
-          <a:ln cap="flat" cmpd="sng" w="12700">
-            <a:solidFill>
-              <a:srgbClr val="FFC93C"/>
-            </a:solidFill>
-            <a:prstDash val="solid"/>
-            <a:round/>
-            <a:headEnd len="sm" w="sm" type="none"/>
-            <a:tailEnd len="sm" w="sm" type="none"/>
-          </a:ln>
-        </p:spPr>
-        <p:txBody>
-          <a:bodyPr anchorCtr="0" anchor="ctr" bIns="91425" lIns="91425" spcFirstLastPara="1" rIns="91425" wrap="square" tIns="91425">
-            <a:noAutofit/>
-          </a:bodyPr>
-          <a:lstStyle/>
-          <a:p>
-            <a:pPr indent="0" lvl="0" marL="0" rtl="0" algn="l">
-              <a:spcBef>
-                <a:spcPts val="0"/>
-              </a:spcBef>
-              <a:spcAft>
-                <a:spcPts val="0"/>
-              </a:spcAft>
-              <a:buNone/>
-            </a:pPr>
-            <a:r>
-              <a:t/>
-            </a:r>
-            <a:endParaRPr/>
-          </a:p>
-        </p:txBody>
-      </p:sp>
-      <p:sp>
-        <p:nvSpPr>
-          <p:cNvPr id="205" name="Google Shape;205;p22"/>
-          <p:cNvSpPr txBox="1"/>
-          <p:nvPr/>
-        </p:nvSpPr>
-        <p:spPr>
-          <a:xfrm>
-            <a:off x="3566160" y="2514600"/>
+            <a:off x="731510" y="2503225"/>
             <a:ext cx="2103000" cy="365700"/>
           </a:xfrm>
           <a:prstGeom prst="rect">
@@ -14260,14 +14238,14 @@
       </p:sp>
       <p:sp>
         <p:nvSpPr>
-          <p:cNvPr id="206" name="Google Shape;206;p22"/>
+          <p:cNvPr id="202" name="Google Shape;202;p22"/>
           <p:cNvSpPr txBox="1"/>
           <p:nvPr/>
         </p:nvSpPr>
         <p:spPr>
           <a:xfrm>
-            <a:off x="3566160" y="2926080"/>
-            <a:ext cx="2103000" cy="731400"/>
+            <a:off x="731495" y="2914700"/>
+            <a:ext cx="3157800" cy="731400"/>
           </a:xfrm>
           <a:prstGeom prst="rect">
             <a:avLst/>
@@ -14307,7 +14285,19 @@
                 <a:cs typeface="Calibri"/>
                 <a:sym typeface="Calibri"/>
               </a:rPr>
-              <a:t>Street crossings, traffic signals, and route guidance.</a:t>
+              <a:t>Assist with t</a:t>
+            </a:r>
+            <a:r>
+              <a:rPr lang="en">
+                <a:solidFill>
+                  <a:srgbClr val="5B6472"/>
+                </a:solidFill>
+                <a:latin typeface="Calibri"/>
+                <a:ea typeface="Calibri"/>
+                <a:cs typeface="Calibri"/>
+                <a:sym typeface="Calibri"/>
+              </a:rPr>
+              <a:t>raffic signals and directions. Can be integrated with existing systems (e.g. Apple Maps API).</a:t>
             </a:r>
             <a:endParaRPr>
               <a:solidFill>
@@ -14351,14 +14341,14 @@
       </p:sp>
       <p:sp>
         <p:nvSpPr>
-          <p:cNvPr id="207" name="Google Shape;207;p22"/>
+          <p:cNvPr id="203" name="Google Shape;203;p22"/>
           <p:cNvSpPr/>
           <p:nvPr/>
         </p:nvSpPr>
         <p:spPr>
           <a:xfrm>
-            <a:off x="6126480" y="1417320"/>
-            <a:ext cx="2560200" cy="2331600"/>
+            <a:off x="4790875" y="1405950"/>
+            <a:ext cx="3870900" cy="2331600"/>
           </a:xfrm>
           <a:prstGeom prst="roundRect">
             <a:avLst>
@@ -14402,13 +14392,13 @@
       </p:sp>
       <p:sp>
         <p:nvSpPr>
-          <p:cNvPr id="208" name="Google Shape;208;p22"/>
+          <p:cNvPr id="204" name="Google Shape;204;p22"/>
           <p:cNvSpPr/>
           <p:nvPr/>
         </p:nvSpPr>
         <p:spPr>
           <a:xfrm>
-            <a:off x="6400800" y="1645920"/>
+            <a:off x="5065200" y="1634545"/>
             <a:ext cx="731400" cy="731400"/>
           </a:xfrm>
           <a:prstGeom prst="ellipse">
@@ -14451,13 +14441,13 @@
       </p:sp>
       <p:sp>
         <p:nvSpPr>
-          <p:cNvPr id="209" name="Google Shape;209;p22"/>
+          <p:cNvPr id="205" name="Google Shape;205;p22"/>
           <p:cNvSpPr txBox="1"/>
           <p:nvPr/>
         </p:nvSpPr>
         <p:spPr>
           <a:xfrm>
-            <a:off x="6400800" y="2514600"/>
+            <a:off x="5065200" y="2503225"/>
             <a:ext cx="2103000" cy="365700"/>
           </a:xfrm>
           <a:prstGeom prst="rect">
@@ -14514,14 +14504,14 @@
       </p:sp>
       <p:sp>
         <p:nvSpPr>
-          <p:cNvPr id="210" name="Google Shape;210;p22"/>
+          <p:cNvPr id="206" name="Google Shape;206;p22"/>
           <p:cNvSpPr txBox="1"/>
           <p:nvPr/>
         </p:nvSpPr>
         <p:spPr>
           <a:xfrm>
-            <a:off x="6400800" y="2926080"/>
-            <a:ext cx="2103000" cy="731400"/>
+            <a:off x="5065200" y="2914700"/>
+            <a:ext cx="3438600" cy="731400"/>
           </a:xfrm>
           <a:prstGeom prst="rect">
             <a:avLst/>
@@ -14561,7 +14551,19 @@
                 <a:cs typeface="Calibri"/>
                 <a:sym typeface="Calibri"/>
               </a:rPr>
-              <a:t>Adjustable voice, sensitivity, and vibration cues.</a:t>
+              <a:t>Create an audio-guided accessibility settings page to adjust</a:t>
+            </a:r>
+            <a:r>
+              <a:rPr lang="en">
+                <a:solidFill>
+                  <a:srgbClr val="5B6472"/>
+                </a:solidFill>
+                <a:latin typeface="Calibri"/>
+                <a:ea typeface="Calibri"/>
+                <a:cs typeface="Calibri"/>
+                <a:sym typeface="Calibri"/>
+              </a:rPr>
+              <a:t> the voice, speed, volume, and vibration.</a:t>
             </a:r>
             <a:endParaRPr>
               <a:solidFill>
@@ -14605,7 +14607,7 @@
       </p:sp>
       <p:sp>
         <p:nvSpPr>
-          <p:cNvPr id="211" name="Google Shape;211;p22"/>
+          <p:cNvPr id="207" name="Google Shape;207;p22"/>
           <p:cNvSpPr/>
           <p:nvPr/>
         </p:nvSpPr>
@@ -14656,7 +14658,7 @@
       </p:sp>
       <p:sp>
         <p:nvSpPr>
-          <p:cNvPr id="212" name="Google Shape;212;p22"/>
+          <p:cNvPr id="208" name="Google Shape;208;p22"/>
           <p:cNvSpPr txBox="1"/>
           <p:nvPr/>
         </p:nvSpPr>
@@ -14703,7 +14705,7 @@
                 <a:cs typeface="Calibri"/>
                 <a:sym typeface="Calibri"/>
               </a:rPr>
-              <a:t>First step: test and co-design with blind and low-vision users.</a:t>
+              <a:t>First step to deployment: test and design with blind and low-vision users.</a:t>
             </a:r>
             <a:endParaRPr b="1" sz="1800">
               <a:solidFill>
@@ -14719,7 +14721,7 @@
       </p:sp>
       <p:pic>
         <p:nvPicPr>
-          <p:cNvPr descr="preencoded.png" id="213" name="Google Shape;213;p22"/>
+          <p:cNvPr descr="preencoded.png" id="209" name="Google Shape;209;p22"/>
           <p:cNvPicPr preferRelativeResize="0"/>
           <p:nvPr/>
         </p:nvPicPr>
@@ -14732,7 +14734,7 @@
         </p:blipFill>
         <p:spPr>
           <a:xfrm>
-            <a:off x="937210" y="1851602"/>
+            <a:off x="937195" y="1840232"/>
             <a:ext cx="320040" cy="320040"/>
           </a:xfrm>
           <a:prstGeom prst="rect">
@@ -14746,7 +14748,7 @@
       </p:pic>
       <p:pic>
         <p:nvPicPr>
-          <p:cNvPr descr="preencoded.png" id="214" name="Google Shape;214;p22"/>
+          <p:cNvPr descr="preencoded.png" id="210" name="Google Shape;210;p22"/>
           <p:cNvPicPr preferRelativeResize="0"/>
           <p:nvPr/>
         </p:nvPicPr>
@@ -14759,34 +14761,7 @@
         </p:blipFill>
         <p:spPr>
           <a:xfrm>
-            <a:off x="3771845" y="1851607"/>
-            <a:ext cx="320040" cy="320040"/>
-          </a:xfrm>
-          <a:prstGeom prst="rect">
-            <a:avLst/>
-          </a:prstGeom>
-          <a:noFill/>
-          <a:ln>
-            <a:noFill/>
-          </a:ln>
-        </p:spPr>
-      </p:pic>
-      <p:pic>
-        <p:nvPicPr>
-          <p:cNvPr descr="preencoded.png" id="215" name="Google Shape;215;p22"/>
-          <p:cNvPicPr preferRelativeResize="0"/>
-          <p:nvPr/>
-        </p:nvPicPr>
-        <p:blipFill rotWithShape="1">
-          <a:blip r:embed="rId5">
-            <a:alphaModFix/>
-          </a:blip>
-          <a:srcRect b="0" l="0" r="0" t="0"/>
-          <a:stretch/>
-        </p:blipFill>
-        <p:spPr>
-          <a:xfrm>
-            <a:off x="6606460" y="1851607"/>
+            <a:off x="5270860" y="1840232"/>
             <a:ext cx="320040" cy="320040"/>
           </a:xfrm>
           <a:prstGeom prst="rect">
@@ -14818,7 +14793,7 @@
     </p:bg>
     <p:spTree>
       <p:nvGrpSpPr>
-        <p:cNvPr id="220" name="Shape 220"/>
+        <p:cNvPr id="215" name="Shape 215"/>
         <p:cNvGrpSpPr/>
         <p:nvPr/>
       </p:nvGrpSpPr>
@@ -14832,7 +14807,7 @@
       </p:grpSpPr>
       <p:sp>
         <p:nvSpPr>
-          <p:cNvPr id="221" name="Google Shape;221;p23"/>
+          <p:cNvPr id="216" name="Google Shape;216;p23"/>
           <p:cNvSpPr/>
           <p:nvPr/>
         </p:nvSpPr>
@@ -14885,7 +14860,7 @@
       </p:sp>
       <p:sp>
         <p:nvSpPr>
-          <p:cNvPr id="222" name="Google Shape;222;p23"/>
+          <p:cNvPr id="217" name="Google Shape;217;p23"/>
           <p:cNvSpPr/>
           <p:nvPr/>
         </p:nvSpPr>
@@ -14938,7 +14913,7 @@
       </p:sp>
       <p:sp>
         <p:nvSpPr>
-          <p:cNvPr id="223" name="Google Shape;223;p23"/>
+          <p:cNvPr id="218" name="Google Shape;218;p23"/>
           <p:cNvSpPr/>
           <p:nvPr/>
         </p:nvSpPr>
@@ -14991,7 +14966,7 @@
       </p:sp>
       <p:sp>
         <p:nvSpPr>
-          <p:cNvPr id="224" name="Google Shape;224;p23"/>
+          <p:cNvPr id="219" name="Google Shape;219;p23"/>
           <p:cNvSpPr/>
           <p:nvPr/>
         </p:nvSpPr>
@@ -15040,7 +15015,7 @@
       </p:sp>
       <p:sp>
         <p:nvSpPr>
-          <p:cNvPr id="225" name="Google Shape;225;p23"/>
+          <p:cNvPr id="220" name="Google Shape;220;p23"/>
           <p:cNvSpPr/>
           <p:nvPr/>
         </p:nvSpPr>
@@ -15091,7 +15066,7 @@
       </p:sp>
       <p:sp>
         <p:nvSpPr>
-          <p:cNvPr id="226" name="Google Shape;226;p23"/>
+          <p:cNvPr id="221" name="Google Shape;221;p23"/>
           <p:cNvSpPr/>
           <p:nvPr/>
         </p:nvSpPr>
@@ -15142,7 +15117,7 @@
       </p:sp>
       <p:sp>
         <p:nvSpPr>
-          <p:cNvPr id="227" name="Google Shape;227;p23"/>
+          <p:cNvPr id="222" name="Google Shape;222;p23"/>
           <p:cNvSpPr/>
           <p:nvPr/>
         </p:nvSpPr>
@@ -15191,7 +15166,7 @@
       </p:sp>
       <p:sp>
         <p:nvSpPr>
-          <p:cNvPr id="228" name="Google Shape;228;p23"/>
+          <p:cNvPr id="223" name="Google Shape;223;p23"/>
           <p:cNvSpPr txBox="1"/>
           <p:nvPr/>
         </p:nvSpPr>
@@ -15413,70 +15388,7 @@
       </p:sp>
       <p:sp>
         <p:nvSpPr>
-          <p:cNvPr id="229" name="Google Shape;229;p23"/>
-          <p:cNvSpPr txBox="1"/>
-          <p:nvPr/>
-        </p:nvSpPr>
-        <p:spPr>
-          <a:xfrm>
-            <a:off x="640080" y="3657600"/>
-            <a:ext cx="5120640" cy="457200"/>
-          </a:xfrm>
-          <a:prstGeom prst="rect">
-            <a:avLst/>
-          </a:prstGeom>
-          <a:noFill/>
-          <a:ln>
-            <a:noFill/>
-          </a:ln>
-        </p:spPr>
-        <p:txBody>
-          <a:bodyPr anchorCtr="0" anchor="ctr" bIns="0" lIns="0" spcFirstLastPara="1" rIns="0" wrap="square" tIns="0">
-            <a:noAutofit/>
-          </a:bodyPr>
-          <a:lstStyle/>
-          <a:p>
-            <a:pPr indent="0" lvl="0" marL="0" marR="0" rtl="0" algn="l">
-              <a:spcBef>
-                <a:spcPts val="0"/>
-              </a:spcBef>
-              <a:spcAft>
-                <a:spcPts val="0"/>
-              </a:spcAft>
-              <a:buClr>
-                <a:srgbClr val="C9CED8"/>
-              </a:buClr>
-              <a:buSzPts val="2200"/>
-              <a:buFont typeface="Calibri"/>
-              <a:buNone/>
-            </a:pPr>
-            <a:r>
-              <a:rPr b="0" i="0" lang="en" sz="2200" u="none" cap="none" strike="noStrike">
-                <a:solidFill>
-                  <a:srgbClr val="C9CED8"/>
-                </a:solidFill>
-                <a:latin typeface="Calibri"/>
-                <a:ea typeface="Calibri"/>
-                <a:cs typeface="Calibri"/>
-                <a:sym typeface="Calibri"/>
-              </a:rPr>
-              <a:t>Thank you. Questions?</a:t>
-            </a:r>
-            <a:endParaRPr b="0" i="0" sz="2200" u="none" cap="none" strike="noStrike">
-              <a:solidFill>
-                <a:schemeClr val="dk1"/>
-              </a:solidFill>
-              <a:latin typeface="Calibri"/>
-              <a:ea typeface="Calibri"/>
-              <a:cs typeface="Calibri"/>
-              <a:sym typeface="Calibri"/>
-            </a:endParaRPr>
-          </a:p>
-        </p:txBody>
-      </p:sp>
-      <p:sp>
-        <p:nvSpPr>
-          <p:cNvPr id="230" name="Google Shape;230;p23"/>
+          <p:cNvPr id="224" name="Google Shape;224;p23"/>
           <p:cNvSpPr txBox="1"/>
           <p:nvPr/>
         </p:nvSpPr>

</xml_diff>